<commit_message>
Prog, Software Architecture, Hexagonal Architecture
</commit_message>
<xml_diff>
--- a/resource/Prog, Software Architecture, Hexagonal Architecture.pptx
+++ b/resource/Prog, Software Architecture, Hexagonal Architecture.pptx
@@ -4345,7 +4345,7 @@
         </p:nvGrpSpPr>
         <p:grpSpPr>
           <a:xfrm>
-            <a:off x="3535608" y="4409985"/>
+            <a:off x="3326040" y="4226431"/>
             <a:ext cx="803233" cy="592871"/>
             <a:chOff x="3767740" y="1649667"/>
             <a:chExt cx="712186" cy="525669"/>
@@ -4500,8 +4500,8 @@
         </p:nvCxnSpPr>
         <p:spPr>
           <a:xfrm rot="5400000">
-            <a:off x="4012088" y="4083230"/>
-            <a:ext cx="250557" cy="402952"/>
+            <a:off x="3999081" y="3886669"/>
+            <a:ext cx="67003" cy="612520"/>
           </a:xfrm>
           <a:prstGeom prst="curvedConnector3">
             <a:avLst>
@@ -4696,8 +4696,8 @@
         </p:nvCxnSpPr>
         <p:spPr>
           <a:xfrm rot="16200000" flipH="1">
-            <a:off x="3959608" y="4979137"/>
-            <a:ext cx="136246" cy="183683"/>
+            <a:off x="3763047" y="4782576"/>
+            <a:ext cx="319800" cy="393251"/>
           </a:xfrm>
           <a:prstGeom prst="curvedConnector3">
             <a:avLst>
@@ -4991,9 +4991,9 @@
         </p:nvGrpSpPr>
         <p:grpSpPr>
           <a:xfrm>
-            <a:off x="4771357" y="5738202"/>
+            <a:off x="4218381" y="4236487"/>
             <a:ext cx="865685" cy="638967"/>
-            <a:chOff x="3767740" y="1649667"/>
+            <a:chOff x="3773705" y="1649667"/>
             <a:chExt cx="712186" cy="525669"/>
           </a:xfrm>
         </p:grpSpPr>
@@ -5069,7 +5069,7 @@
           </p:nvSpPr>
           <p:spPr>
             <a:xfrm>
-              <a:off x="3767740" y="1763053"/>
+              <a:off x="3773705" y="1809833"/>
               <a:ext cx="712186" cy="253204"/>
             </a:xfrm>
             <a:prstGeom prst="rect">
@@ -5176,19 +5176,17 @@
           <p:cNvCxnSpPr>
             <a:cxnSpLocks/>
             <a:stCxn id="89" idx="4"/>
-            <a:endCxn id="82" idx="0"/>
+            <a:endCxn id="82" idx="6"/>
           </p:cNvCxnSpPr>
           <p:nvPr/>
         </p:nvCxnSpPr>
         <p:spPr>
           <a:xfrm rot="5400000">
-            <a:off x="4739046" y="4546649"/>
-            <a:ext cx="1655268" cy="727838"/>
+            <a:off x="5209790" y="3835161"/>
+            <a:ext cx="473036" cy="968583"/>
           </a:xfrm>
-          <a:prstGeom prst="curvedConnector3">
-            <a:avLst>
-              <a:gd name="adj1" fmla="val 50000"/>
-            </a:avLst>
+          <a:prstGeom prst="curvedConnector2">
+            <a:avLst/>
           </a:prstGeom>
           <a:ln>
             <a:prstDash val="sysDot"/>
@@ -5225,9 +5223,9 @@
         </p:nvGrpSpPr>
         <p:grpSpPr>
           <a:xfrm>
-            <a:off x="5499195" y="3443967"/>
+            <a:off x="5497756" y="3443967"/>
             <a:ext cx="865685" cy="638967"/>
-            <a:chOff x="3767740" y="1649667"/>
+            <a:chOff x="3766556" y="1649667"/>
             <a:chExt cx="712186" cy="525669"/>
           </a:xfrm>
         </p:grpSpPr>
@@ -5303,7 +5301,7 @@
           </p:nvSpPr>
           <p:spPr>
             <a:xfrm>
-              <a:off x="3767740" y="1763053"/>
+              <a:off x="3766556" y="1784614"/>
               <a:ext cx="712186" cy="253204"/>
             </a:xfrm>
             <a:prstGeom prst="rect">
@@ -5348,34 +5346,33 @@
       </p:grpSp>
       <p:cxnSp>
         <p:nvCxnSpPr>
-          <p:cNvPr id="92" name="연결선: 구부러짐 91">
-            <a:extLst>
-              <a:ext uri="{FF2B5EF4-FFF2-40B4-BE49-F238E27FC236}">
-                <a16:creationId xmlns:a16="http://schemas.microsoft.com/office/drawing/2014/main" id="{9B215FF2-D122-3648-F6CF-5AA490AC6A15}"/>
+          <p:cNvPr id="10" name="연결선: 구부러짐 9">
+            <a:extLst>
+              <a:ext uri="{FF2B5EF4-FFF2-40B4-BE49-F238E27FC236}">
+                <a16:creationId xmlns:a16="http://schemas.microsoft.com/office/drawing/2014/main" id="{C939F653-ECC7-9224-C6B2-D7593BED05CE}"/>
               </a:ext>
             </a:extLst>
           </p:cNvPr>
           <p:cNvCxnSpPr>
             <a:cxnSpLocks/>
-            <a:stCxn id="21" idx="5"/>
-            <a:endCxn id="63" idx="5"/>
+            <a:stCxn id="63" idx="4"/>
+            <a:endCxn id="82" idx="2"/>
           </p:cNvCxnSpPr>
           <p:nvPr/>
         </p:nvCxnSpPr>
         <p:spPr>
-          <a:xfrm rot="5400000">
-            <a:off x="3645653" y="3298041"/>
-            <a:ext cx="2117840" cy="1118143"/>
+          <a:xfrm rot="5400000" flipH="1" flipV="1">
+            <a:off x="3893020" y="4389272"/>
+            <a:ext cx="263332" cy="596728"/>
           </a:xfrm>
-          <a:prstGeom prst="curvedConnector3">
+          <a:prstGeom prst="curvedConnector4">
             <a:avLst>
-              <a:gd name="adj1" fmla="val 98416"/>
+              <a:gd name="adj1" fmla="val -30247"/>
+              <a:gd name="adj2" fmla="val 74838"/>
             </a:avLst>
           </a:prstGeom>
           <a:ln>
-            <a:prstDash val="solid"/>
-            <a:headEnd type="arrow"/>
-            <a:tailEnd type="none"/>
+            <a:tailEnd type="triangle"/>
           </a:ln>
         </p:spPr>
         <p:style>

</xml_diff>